<commit_message>
UNet ottimizzato: 50 epoche CPU, 29.89dB (+5.8dB) con architettura snella 1.9M params
</commit_message>
<xml_diff>
--- a/slides/presentazione.pptx
+++ b/slides/presentazione.pptx
@@ -5,18 +5,18 @@
     <p:sldMasterId id="2147483648" r:id="rId1"/>
   </p:sldMasterIdLst>
   <p:sldIdLst>
-    <p:sldId id="256" r:id="rId7"/>
-    <p:sldId id="257" r:id="rId8"/>
-    <p:sldId id="258" r:id="rId9"/>
-    <p:sldId id="259" r:id="rId10"/>
-    <p:sldId id="260" r:id="rId11"/>
-    <p:sldId id="261" r:id="rId12"/>
-    <p:sldId id="262" r:id="rId13"/>
-    <p:sldId id="263" r:id="rId14"/>
-    <p:sldId id="264" r:id="rId15"/>
-    <p:sldId id="265" r:id="rId16"/>
+    <p:sldId id="256" r:id="rId2"/>
+    <p:sldId id="257" r:id="rId3"/>
+    <p:sldId id="258" r:id="rId4"/>
+    <p:sldId id="259" r:id="rId5"/>
+    <p:sldId id="260" r:id="rId6"/>
+    <p:sldId id="261" r:id="rId7"/>
+    <p:sldId id="262" r:id="rId8"/>
+    <p:sldId id="263" r:id="rId9"/>
+    <p:sldId id="264" r:id="rId10"/>
+    <p:sldId id="265" r:id="rId11"/>
   </p:sldIdLst>
-  <p:sldSz cx="12191695" cy="6858000" type="screen4x3"/>
+  <p:sldSz cx="12192000" cy="6858000"/>
   <p:notesSz cx="6858000" cy="9144000"/>
   <p:defaultTextStyle>
     <a:defPPr>
@@ -113,7 +113,67 @@
       </a:defRPr>
     </a:lvl9pPr>
   </p:defaultTextStyle>
+  <p:extLst>
+    <p:ext uri="{EFAFB233-063F-42B5-8137-9DF3F51BA10A}">
+      <p15:sldGuideLst xmlns:p15="http://schemas.microsoft.com/office/powerpoint/2012/main">
+        <p15:guide id="1" orient="horz" pos="2160">
+          <p15:clr>
+            <a:srgbClr val="A4A3A4"/>
+          </p15:clr>
+        </p15:guide>
+        <p15:guide id="2" pos="2880">
+          <p15:clr>
+            <a:srgbClr val="A4A3A4"/>
+          </p15:clr>
+        </p15:guide>
+      </p15:sldGuideLst>
+    </p:ext>
+  </p:extLst>
 </p:presentation>
+</file>
+
+<file path=ppt/changesInfos/changesInfo1.xml><?xml version="1.0" encoding="utf-8"?>
+<pc:chgInfo xmlns:a="http://schemas.openxmlformats.org/drawingml/2006/main" xmlns:r="http://schemas.openxmlformats.org/officeDocument/2006/relationships" xmlns:ac="http://schemas.microsoft.com/office/drawing/2013/main/command" xmlns:pc="http://schemas.microsoft.com/office/powerpoint/2013/main/command">
+  <pc:docChgLst>
+    <pc:chgData name="Francesco Castaldi" userId="872a80c9-521e-4bea-8f54-636f116dac91" providerId="ADAL" clId="{A28509A5-53B9-443F-B1D9-24983923E08E}"/>
+    <pc:docChg chg="mod modSld modMainMaster">
+      <pc:chgData name="Francesco Castaldi" userId="872a80c9-521e-4bea-8f54-636f116dac91" providerId="ADAL" clId="{A28509A5-53B9-443F-B1D9-24983923E08E}" dt="2026-06-10T13:45:31.526" v="11" actId="1076"/>
+      <pc:docMkLst>
+        <pc:docMk/>
+      </pc:docMkLst>
+      <pc:sldChg chg="modSp mod">
+        <pc:chgData name="Francesco Castaldi" userId="872a80c9-521e-4bea-8f54-636f116dac91" providerId="ADAL" clId="{A28509A5-53B9-443F-B1D9-24983923E08E}" dt="2026-06-10T13:45:31.526" v="11" actId="1076"/>
+        <pc:sldMkLst>
+          <pc:docMk/>
+          <pc:sldMk cId="0" sldId="256"/>
+        </pc:sldMkLst>
+        <pc:spChg chg="mod">
+          <ac:chgData name="Francesco Castaldi" userId="872a80c9-521e-4bea-8f54-636f116dac91" providerId="ADAL" clId="{A28509A5-53B9-443F-B1D9-24983923E08E}" dt="2026-06-10T13:45:31.526" v="11" actId="1076"/>
+          <ac:spMkLst>
+            <pc:docMk/>
+            <pc:sldMk cId="0" sldId="256"/>
+            <ac:spMk id="4" creationId="{00000000-0000-0000-0000-000000000000}"/>
+          </ac:spMkLst>
+        </pc:spChg>
+      </pc:sldChg>
+      <pc:sldMasterChg chg="addSp mod">
+        <pc:chgData name="Francesco Castaldi" userId="872a80c9-521e-4bea-8f54-636f116dac91" providerId="ADAL" clId="{A28509A5-53B9-443F-B1D9-24983923E08E}" dt="2026-06-10T13:45:27.967" v="9" actId="33475"/>
+        <pc:sldMasterMkLst>
+          <pc:docMk/>
+          <pc:sldMasterMk cId="2209977519" sldId="2147483648"/>
+        </pc:sldMasterMkLst>
+        <pc:spChg chg="add">
+          <ac:chgData name="Francesco Castaldi" userId="872a80c9-521e-4bea-8f54-636f116dac91" providerId="ADAL" clId="{A28509A5-53B9-443F-B1D9-24983923E08E}" dt="2026-06-10T13:45:27.967" v="9" actId="33475"/>
+          <ac:spMkLst>
+            <pc:docMk/>
+            <pc:sldMasterMk cId="2209977519" sldId="2147483648"/>
+            <ac:spMk id="8" creationId="{EB16607D-0606-71E1-27A6-8A3745876565}"/>
+          </ac:spMkLst>
+        </pc:spChg>
+      </pc:sldMasterChg>
+    </pc:docChg>
+  </pc:docChgLst>
+</pc:chgInfo>
 </file>
 
 <file path=ppt/slideLayouts/slideLayout1.xml><?xml version="1.0" encoding="utf-8"?>
@@ -154,10 +214,9 @@
           <a:lstStyle/>
           <a:p>
             <a:r>
-              <a:rPr lang="en-US" smtClean="0"/>
+              <a:rPr lang="en-US"/>
               <a:t>Click to edit Master title style</a:t>
             </a:r>
-            <a:endParaRPr lang="en-US"/>
           </a:p>
         </p:txBody>
       </p:sp>
@@ -273,10 +332,9 @@
           </a:lstStyle>
           <a:p>
             <a:r>
-              <a:rPr lang="en-US" smtClean="0"/>
+              <a:rPr lang="en-US"/>
               <a:t>Click to edit Master subtitle style</a:t>
             </a:r>
-            <a:endParaRPr lang="en-US"/>
           </a:p>
         </p:txBody>
       </p:sp>
@@ -297,7 +355,7 @@
           <a:p>
             <a:fld id="{5BCAD085-E8A6-8845-BD4E-CB4CCA059FC4}" type="datetimeFigureOut">
               <a:rPr lang="en-US" smtClean="0"/>
-              <a:t>1/27/13</a:t>
+              <a:t>6/10/2026</a:t>
             </a:fld>
             <a:endParaRPr lang="en-US"/>
           </a:p>
@@ -339,7 +397,7 @@
           <a:p>
             <a:fld id="{C1FF6DA9-008F-8B48-92A6-B652298478BF}" type="slidenum">
               <a:rPr lang="en-US" smtClean="0"/>
-              <a:t>‹#›</a:t>
+              <a:t>‹N›</a:t>
             </a:fld>
             <a:endParaRPr lang="en-US"/>
           </a:p>
@@ -391,10 +449,9 @@
           <a:lstStyle/>
           <a:p>
             <a:r>
-              <a:rPr lang="en-US" smtClean="0"/>
+              <a:rPr lang="en-US"/>
               <a:t>Click to edit Master title style</a:t>
             </a:r>
-            <a:endParaRPr lang="en-US"/>
           </a:p>
         </p:txBody>
       </p:sp>
@@ -415,38 +472,37 @@
           <a:p>
             <a:pPr lvl="0"/>
             <a:r>
-              <a:rPr lang="en-US" smtClean="0"/>
+              <a:rPr lang="en-US"/>
               <a:t>Click to edit Master text styles</a:t>
             </a:r>
           </a:p>
           <a:p>
             <a:pPr lvl="1"/>
             <a:r>
-              <a:rPr lang="en-US" smtClean="0"/>
+              <a:rPr lang="en-US"/>
               <a:t>Second level</a:t>
             </a:r>
           </a:p>
           <a:p>
             <a:pPr lvl="2"/>
             <a:r>
-              <a:rPr lang="en-US" smtClean="0"/>
+              <a:rPr lang="en-US"/>
               <a:t>Third level</a:t>
             </a:r>
           </a:p>
           <a:p>
             <a:pPr lvl="3"/>
             <a:r>
-              <a:rPr lang="en-US" smtClean="0"/>
+              <a:rPr lang="en-US"/>
               <a:t>Fourth level</a:t>
             </a:r>
           </a:p>
           <a:p>
             <a:pPr lvl="4"/>
             <a:r>
-              <a:rPr lang="en-US" smtClean="0"/>
+              <a:rPr lang="en-US"/>
               <a:t>Fifth level</a:t>
             </a:r>
-            <a:endParaRPr lang="en-US"/>
           </a:p>
         </p:txBody>
       </p:sp>
@@ -467,7 +523,7 @@
           <a:p>
             <a:fld id="{5BCAD085-E8A6-8845-BD4E-CB4CCA059FC4}" type="datetimeFigureOut">
               <a:rPr lang="en-US" smtClean="0"/>
-              <a:t>1/27/13</a:t>
+              <a:t>6/10/2026</a:t>
             </a:fld>
             <a:endParaRPr lang="en-US"/>
           </a:p>
@@ -509,7 +565,7 @@
           <a:p>
             <a:fld id="{C1FF6DA9-008F-8B48-92A6-B652298478BF}" type="slidenum">
               <a:rPr lang="en-US" smtClean="0"/>
-              <a:t>‹#›</a:t>
+              <a:t>‹N›</a:t>
             </a:fld>
             <a:endParaRPr lang="en-US"/>
           </a:p>
@@ -566,10 +622,9 @@
           <a:lstStyle/>
           <a:p>
             <a:r>
-              <a:rPr lang="en-US" smtClean="0"/>
+              <a:rPr lang="en-US"/>
               <a:t>Click to edit Master title style</a:t>
             </a:r>
-            <a:endParaRPr lang="en-US"/>
           </a:p>
         </p:txBody>
       </p:sp>
@@ -595,38 +650,37 @@
           <a:p>
             <a:pPr lvl="0"/>
             <a:r>
-              <a:rPr lang="en-US" smtClean="0"/>
+              <a:rPr lang="en-US"/>
               <a:t>Click to edit Master text styles</a:t>
             </a:r>
           </a:p>
           <a:p>
             <a:pPr lvl="1"/>
             <a:r>
-              <a:rPr lang="en-US" smtClean="0"/>
+              <a:rPr lang="en-US"/>
               <a:t>Second level</a:t>
             </a:r>
           </a:p>
           <a:p>
             <a:pPr lvl="2"/>
             <a:r>
-              <a:rPr lang="en-US" smtClean="0"/>
+              <a:rPr lang="en-US"/>
               <a:t>Third level</a:t>
             </a:r>
           </a:p>
           <a:p>
             <a:pPr lvl="3"/>
             <a:r>
-              <a:rPr lang="en-US" smtClean="0"/>
+              <a:rPr lang="en-US"/>
               <a:t>Fourth level</a:t>
             </a:r>
           </a:p>
           <a:p>
             <a:pPr lvl="4"/>
             <a:r>
-              <a:rPr lang="en-US" smtClean="0"/>
+              <a:rPr lang="en-US"/>
               <a:t>Fifth level</a:t>
             </a:r>
-            <a:endParaRPr lang="en-US"/>
           </a:p>
         </p:txBody>
       </p:sp>
@@ -647,7 +701,7 @@
           <a:p>
             <a:fld id="{5BCAD085-E8A6-8845-BD4E-CB4CCA059FC4}" type="datetimeFigureOut">
               <a:rPr lang="en-US" smtClean="0"/>
-              <a:t>1/27/13</a:t>
+              <a:t>6/10/2026</a:t>
             </a:fld>
             <a:endParaRPr lang="en-US"/>
           </a:p>
@@ -689,7 +743,7 @@
           <a:p>
             <a:fld id="{C1FF6DA9-008F-8B48-92A6-B652298478BF}" type="slidenum">
               <a:rPr lang="en-US" smtClean="0"/>
-              <a:t>‹#›</a:t>
+              <a:t>‹N›</a:t>
             </a:fld>
             <a:endParaRPr lang="en-US"/>
           </a:p>
@@ -741,10 +795,9 @@
           <a:lstStyle/>
           <a:p>
             <a:r>
-              <a:rPr lang="en-US" smtClean="0"/>
+              <a:rPr lang="en-US"/>
               <a:t>Click to edit Master title style</a:t>
             </a:r>
-            <a:endParaRPr lang="en-US"/>
           </a:p>
         </p:txBody>
       </p:sp>
@@ -765,38 +818,37 @@
           <a:p>
             <a:pPr lvl="0"/>
             <a:r>
-              <a:rPr lang="en-US" smtClean="0"/>
+              <a:rPr lang="en-US"/>
               <a:t>Click to edit Master text styles</a:t>
             </a:r>
           </a:p>
           <a:p>
             <a:pPr lvl="1"/>
             <a:r>
-              <a:rPr lang="en-US" smtClean="0"/>
+              <a:rPr lang="en-US"/>
               <a:t>Second level</a:t>
             </a:r>
           </a:p>
           <a:p>
             <a:pPr lvl="2"/>
             <a:r>
-              <a:rPr lang="en-US" smtClean="0"/>
+              <a:rPr lang="en-US"/>
               <a:t>Third level</a:t>
             </a:r>
           </a:p>
           <a:p>
             <a:pPr lvl="3"/>
             <a:r>
-              <a:rPr lang="en-US" smtClean="0"/>
+              <a:rPr lang="en-US"/>
               <a:t>Fourth level</a:t>
             </a:r>
           </a:p>
           <a:p>
             <a:pPr lvl="4"/>
             <a:r>
-              <a:rPr lang="en-US" smtClean="0"/>
+              <a:rPr lang="en-US"/>
               <a:t>Fifth level</a:t>
             </a:r>
-            <a:endParaRPr lang="en-US"/>
           </a:p>
         </p:txBody>
       </p:sp>
@@ -817,7 +869,7 @@
           <a:p>
             <a:fld id="{5BCAD085-E8A6-8845-BD4E-CB4CCA059FC4}" type="datetimeFigureOut">
               <a:rPr lang="en-US" smtClean="0"/>
-              <a:t>1/27/13</a:t>
+              <a:t>6/10/2026</a:t>
             </a:fld>
             <a:endParaRPr lang="en-US"/>
           </a:p>
@@ -859,7 +911,7 @@
           <a:p>
             <a:fld id="{C1FF6DA9-008F-8B48-92A6-B652298478BF}" type="slidenum">
               <a:rPr lang="en-US" smtClean="0"/>
-              <a:t>‹#›</a:t>
+              <a:t>‹N›</a:t>
             </a:fld>
             <a:endParaRPr lang="en-US"/>
           </a:p>
@@ -920,10 +972,9 @@
           </a:lstStyle>
           <a:p>
             <a:r>
-              <a:rPr lang="en-US" smtClean="0"/>
+              <a:rPr lang="en-US"/>
               <a:t>Click to edit Master title style</a:t>
             </a:r>
-            <a:endParaRPr lang="en-US"/>
           </a:p>
         </p:txBody>
       </p:sp>
@@ -1040,7 +1091,7 @@
           <a:p>
             <a:pPr lvl="0"/>
             <a:r>
-              <a:rPr lang="en-US" smtClean="0"/>
+              <a:rPr lang="en-US"/>
               <a:t>Click to edit Master text styles</a:t>
             </a:r>
           </a:p>
@@ -1063,7 +1114,7 @@
           <a:p>
             <a:fld id="{5BCAD085-E8A6-8845-BD4E-CB4CCA059FC4}" type="datetimeFigureOut">
               <a:rPr lang="en-US" smtClean="0"/>
-              <a:t>1/27/13</a:t>
+              <a:t>6/10/2026</a:t>
             </a:fld>
             <a:endParaRPr lang="en-US"/>
           </a:p>
@@ -1105,7 +1156,7 @@
           <a:p>
             <a:fld id="{C1FF6DA9-008F-8B48-92A6-B652298478BF}" type="slidenum">
               <a:rPr lang="en-US" smtClean="0"/>
-              <a:t>‹#›</a:t>
+              <a:t>‹N›</a:t>
             </a:fld>
             <a:endParaRPr lang="en-US"/>
           </a:p>
@@ -1157,10 +1208,9 @@
           <a:lstStyle/>
           <a:p>
             <a:r>
-              <a:rPr lang="en-US" smtClean="0"/>
+              <a:rPr lang="en-US"/>
               <a:t>Click to edit Master title style</a:t>
             </a:r>
-            <a:endParaRPr lang="en-US"/>
           </a:p>
         </p:txBody>
       </p:sp>
@@ -1214,38 +1264,37 @@
           <a:p>
             <a:pPr lvl="0"/>
             <a:r>
-              <a:rPr lang="en-US" smtClean="0"/>
+              <a:rPr lang="en-US"/>
               <a:t>Click to edit Master text styles</a:t>
             </a:r>
           </a:p>
           <a:p>
             <a:pPr lvl="1"/>
             <a:r>
-              <a:rPr lang="en-US" smtClean="0"/>
+              <a:rPr lang="en-US"/>
               <a:t>Second level</a:t>
             </a:r>
           </a:p>
           <a:p>
             <a:pPr lvl="2"/>
             <a:r>
-              <a:rPr lang="en-US" smtClean="0"/>
+              <a:rPr lang="en-US"/>
               <a:t>Third level</a:t>
             </a:r>
           </a:p>
           <a:p>
             <a:pPr lvl="3"/>
             <a:r>
-              <a:rPr lang="en-US" smtClean="0"/>
+              <a:rPr lang="en-US"/>
               <a:t>Fourth level</a:t>
             </a:r>
           </a:p>
           <a:p>
             <a:pPr lvl="4"/>
             <a:r>
-              <a:rPr lang="en-US" smtClean="0"/>
+              <a:rPr lang="en-US"/>
               <a:t>Fifth level</a:t>
             </a:r>
-            <a:endParaRPr lang="en-US"/>
           </a:p>
         </p:txBody>
       </p:sp>
@@ -1299,38 +1348,37 @@
           <a:p>
             <a:pPr lvl="0"/>
             <a:r>
-              <a:rPr lang="en-US" smtClean="0"/>
+              <a:rPr lang="en-US"/>
               <a:t>Click to edit Master text styles</a:t>
             </a:r>
           </a:p>
           <a:p>
             <a:pPr lvl="1"/>
             <a:r>
-              <a:rPr lang="en-US" smtClean="0"/>
+              <a:rPr lang="en-US"/>
               <a:t>Second level</a:t>
             </a:r>
           </a:p>
           <a:p>
             <a:pPr lvl="2"/>
             <a:r>
-              <a:rPr lang="en-US" smtClean="0"/>
+              <a:rPr lang="en-US"/>
               <a:t>Third level</a:t>
             </a:r>
           </a:p>
           <a:p>
             <a:pPr lvl="3"/>
             <a:r>
-              <a:rPr lang="en-US" smtClean="0"/>
+              <a:rPr lang="en-US"/>
               <a:t>Fourth level</a:t>
             </a:r>
           </a:p>
           <a:p>
             <a:pPr lvl="4"/>
             <a:r>
-              <a:rPr lang="en-US" smtClean="0"/>
+              <a:rPr lang="en-US"/>
               <a:t>Fifth level</a:t>
             </a:r>
-            <a:endParaRPr lang="en-US"/>
           </a:p>
         </p:txBody>
       </p:sp>
@@ -1351,7 +1399,7 @@
           <a:p>
             <a:fld id="{5BCAD085-E8A6-8845-BD4E-CB4CCA059FC4}" type="datetimeFigureOut">
               <a:rPr lang="en-US" smtClean="0"/>
-              <a:t>1/27/13</a:t>
+              <a:t>6/10/2026</a:t>
             </a:fld>
             <a:endParaRPr lang="en-US"/>
           </a:p>
@@ -1393,7 +1441,7 @@
           <a:p>
             <a:fld id="{C1FF6DA9-008F-8B48-92A6-B652298478BF}" type="slidenum">
               <a:rPr lang="en-US" smtClean="0"/>
-              <a:t>‹#›</a:t>
+              <a:t>‹N›</a:t>
             </a:fld>
             <a:endParaRPr lang="en-US"/>
           </a:p>
@@ -1449,10 +1497,9 @@
           </a:lstStyle>
           <a:p>
             <a:r>
-              <a:rPr lang="en-US" smtClean="0"/>
+              <a:rPr lang="en-US"/>
               <a:t>Click to edit Master title style</a:t>
             </a:r>
-            <a:endParaRPr lang="en-US"/>
           </a:p>
         </p:txBody>
       </p:sp>
@@ -1515,7 +1562,7 @@
           <a:p>
             <a:pPr lvl="0"/>
             <a:r>
-              <a:rPr lang="en-US" smtClean="0"/>
+              <a:rPr lang="en-US"/>
               <a:t>Click to edit Master text styles</a:t>
             </a:r>
           </a:p>
@@ -1571,38 +1618,37 @@
           <a:p>
             <a:pPr lvl="0"/>
             <a:r>
-              <a:rPr lang="en-US" smtClean="0"/>
+              <a:rPr lang="en-US"/>
               <a:t>Click to edit Master text styles</a:t>
             </a:r>
           </a:p>
           <a:p>
             <a:pPr lvl="1"/>
             <a:r>
-              <a:rPr lang="en-US" smtClean="0"/>
+              <a:rPr lang="en-US"/>
               <a:t>Second level</a:t>
             </a:r>
           </a:p>
           <a:p>
             <a:pPr lvl="2"/>
             <a:r>
-              <a:rPr lang="en-US" smtClean="0"/>
+              <a:rPr lang="en-US"/>
               <a:t>Third level</a:t>
             </a:r>
           </a:p>
           <a:p>
             <a:pPr lvl="3"/>
             <a:r>
-              <a:rPr lang="en-US" smtClean="0"/>
+              <a:rPr lang="en-US"/>
               <a:t>Fourth level</a:t>
             </a:r>
           </a:p>
           <a:p>
             <a:pPr lvl="4"/>
             <a:r>
-              <a:rPr lang="en-US" smtClean="0"/>
+              <a:rPr lang="en-US"/>
               <a:t>Fifth level</a:t>
             </a:r>
-            <a:endParaRPr lang="en-US"/>
           </a:p>
         </p:txBody>
       </p:sp>
@@ -1665,7 +1711,7 @@
           <a:p>
             <a:pPr lvl="0"/>
             <a:r>
-              <a:rPr lang="en-US" smtClean="0"/>
+              <a:rPr lang="en-US"/>
               <a:t>Click to edit Master text styles</a:t>
             </a:r>
           </a:p>
@@ -1721,38 +1767,37 @@
           <a:p>
             <a:pPr lvl="0"/>
             <a:r>
-              <a:rPr lang="en-US" smtClean="0"/>
+              <a:rPr lang="en-US"/>
               <a:t>Click to edit Master text styles</a:t>
             </a:r>
           </a:p>
           <a:p>
             <a:pPr lvl="1"/>
             <a:r>
-              <a:rPr lang="en-US" smtClean="0"/>
+              <a:rPr lang="en-US"/>
               <a:t>Second level</a:t>
             </a:r>
           </a:p>
           <a:p>
             <a:pPr lvl="2"/>
             <a:r>
-              <a:rPr lang="en-US" smtClean="0"/>
+              <a:rPr lang="en-US"/>
               <a:t>Third level</a:t>
             </a:r>
           </a:p>
           <a:p>
             <a:pPr lvl="3"/>
             <a:r>
-              <a:rPr lang="en-US" smtClean="0"/>
+              <a:rPr lang="en-US"/>
               <a:t>Fourth level</a:t>
             </a:r>
           </a:p>
           <a:p>
             <a:pPr lvl="4"/>
             <a:r>
-              <a:rPr lang="en-US" smtClean="0"/>
+              <a:rPr lang="en-US"/>
               <a:t>Fifth level</a:t>
             </a:r>
-            <a:endParaRPr lang="en-US"/>
           </a:p>
         </p:txBody>
       </p:sp>
@@ -1773,7 +1818,7 @@
           <a:p>
             <a:fld id="{5BCAD085-E8A6-8845-BD4E-CB4CCA059FC4}" type="datetimeFigureOut">
               <a:rPr lang="en-US" smtClean="0"/>
-              <a:t>1/27/13</a:t>
+              <a:t>6/10/2026</a:t>
             </a:fld>
             <a:endParaRPr lang="en-US"/>
           </a:p>
@@ -1815,7 +1860,7 @@
           <a:p>
             <a:fld id="{C1FF6DA9-008F-8B48-92A6-B652298478BF}" type="slidenum">
               <a:rPr lang="en-US" smtClean="0"/>
-              <a:t>‹#›</a:t>
+              <a:t>‹N›</a:t>
             </a:fld>
             <a:endParaRPr lang="en-US"/>
           </a:p>
@@ -1867,10 +1912,9 @@
           <a:lstStyle/>
           <a:p>
             <a:r>
-              <a:rPr lang="en-US" smtClean="0"/>
+              <a:rPr lang="en-US"/>
               <a:t>Click to edit Master title style</a:t>
             </a:r>
-            <a:endParaRPr lang="en-US"/>
           </a:p>
         </p:txBody>
       </p:sp>
@@ -1891,7 +1935,7 @@
           <a:p>
             <a:fld id="{5BCAD085-E8A6-8845-BD4E-CB4CCA059FC4}" type="datetimeFigureOut">
               <a:rPr lang="en-US" smtClean="0"/>
-              <a:t>1/27/13</a:t>
+              <a:t>6/10/2026</a:t>
             </a:fld>
             <a:endParaRPr lang="en-US"/>
           </a:p>
@@ -1933,7 +1977,7 @@
           <a:p>
             <a:fld id="{C1FF6DA9-008F-8B48-92A6-B652298478BF}" type="slidenum">
               <a:rPr lang="en-US" smtClean="0"/>
-              <a:t>‹#›</a:t>
+              <a:t>‹N›</a:t>
             </a:fld>
             <a:endParaRPr lang="en-US"/>
           </a:p>
@@ -1986,7 +2030,7 @@
           <a:p>
             <a:fld id="{5BCAD085-E8A6-8845-BD4E-CB4CCA059FC4}" type="datetimeFigureOut">
               <a:rPr lang="en-US" smtClean="0"/>
-              <a:t>1/27/13</a:t>
+              <a:t>6/10/2026</a:t>
             </a:fld>
             <a:endParaRPr lang="en-US"/>
           </a:p>
@@ -2028,7 +2072,7 @@
           <a:p>
             <a:fld id="{C1FF6DA9-008F-8B48-92A6-B652298478BF}" type="slidenum">
               <a:rPr lang="en-US" smtClean="0"/>
-              <a:t>‹#›</a:t>
+              <a:t>‹N›</a:t>
             </a:fld>
             <a:endParaRPr lang="en-US"/>
           </a:p>
@@ -2089,10 +2133,9 @@
           </a:lstStyle>
           <a:p>
             <a:r>
-              <a:rPr lang="en-US" smtClean="0"/>
+              <a:rPr lang="en-US"/>
               <a:t>Click to edit Master title style</a:t>
             </a:r>
-            <a:endParaRPr lang="en-US"/>
           </a:p>
         </p:txBody>
       </p:sp>
@@ -2146,38 +2189,37 @@
           <a:p>
             <a:pPr lvl="0"/>
             <a:r>
-              <a:rPr lang="en-US" smtClean="0"/>
+              <a:rPr lang="en-US"/>
               <a:t>Click to edit Master text styles</a:t>
             </a:r>
           </a:p>
           <a:p>
             <a:pPr lvl="1"/>
             <a:r>
-              <a:rPr lang="en-US" smtClean="0"/>
+              <a:rPr lang="en-US"/>
               <a:t>Second level</a:t>
             </a:r>
           </a:p>
           <a:p>
             <a:pPr lvl="2"/>
             <a:r>
-              <a:rPr lang="en-US" smtClean="0"/>
+              <a:rPr lang="en-US"/>
               <a:t>Third level</a:t>
             </a:r>
           </a:p>
           <a:p>
             <a:pPr lvl="3"/>
             <a:r>
-              <a:rPr lang="en-US" smtClean="0"/>
+              <a:rPr lang="en-US"/>
               <a:t>Fourth level</a:t>
             </a:r>
           </a:p>
           <a:p>
             <a:pPr lvl="4"/>
             <a:r>
-              <a:rPr lang="en-US" smtClean="0"/>
+              <a:rPr lang="en-US"/>
               <a:t>Fifth level</a:t>
             </a:r>
-            <a:endParaRPr lang="en-US"/>
           </a:p>
         </p:txBody>
       </p:sp>
@@ -2240,7 +2282,7 @@
           <a:p>
             <a:pPr lvl="0"/>
             <a:r>
-              <a:rPr lang="en-US" smtClean="0"/>
+              <a:rPr lang="en-US"/>
               <a:t>Click to edit Master text styles</a:t>
             </a:r>
           </a:p>
@@ -2263,7 +2305,7 @@
           <a:p>
             <a:fld id="{5BCAD085-E8A6-8845-BD4E-CB4CCA059FC4}" type="datetimeFigureOut">
               <a:rPr lang="en-US" smtClean="0"/>
-              <a:t>1/27/13</a:t>
+              <a:t>6/10/2026</a:t>
             </a:fld>
             <a:endParaRPr lang="en-US"/>
           </a:p>
@@ -2305,7 +2347,7 @@
           <a:p>
             <a:fld id="{C1FF6DA9-008F-8B48-92A6-B652298478BF}" type="slidenum">
               <a:rPr lang="en-US" smtClean="0"/>
-              <a:t>‹#›</a:t>
+              <a:t>‹N›</a:t>
             </a:fld>
             <a:endParaRPr lang="en-US"/>
           </a:p>
@@ -2366,10 +2408,9 @@
           </a:lstStyle>
           <a:p>
             <a:r>
-              <a:rPr lang="en-US" smtClean="0"/>
+              <a:rPr lang="en-US"/>
               <a:t>Click to edit Master title style</a:t>
             </a:r>
-            <a:endParaRPr lang="en-US"/>
           </a:p>
         </p:txBody>
       </p:sp>
@@ -2493,7 +2534,7 @@
           <a:p>
             <a:pPr lvl="0"/>
             <a:r>
-              <a:rPr lang="en-US" smtClean="0"/>
+              <a:rPr lang="en-US"/>
               <a:t>Click to edit Master text styles</a:t>
             </a:r>
           </a:p>
@@ -2516,7 +2557,7 @@
           <a:p>
             <a:fld id="{5BCAD085-E8A6-8845-BD4E-CB4CCA059FC4}" type="datetimeFigureOut">
               <a:rPr lang="en-US" smtClean="0"/>
-              <a:t>1/27/13</a:t>
+              <a:t>6/10/2026</a:t>
             </a:fld>
             <a:endParaRPr lang="en-US"/>
           </a:p>
@@ -2558,7 +2599,7 @@
           <a:p>
             <a:fld id="{C1FF6DA9-008F-8B48-92A6-B652298478BF}" type="slidenum">
               <a:rPr lang="en-US" smtClean="0"/>
-              <a:t>‹#›</a:t>
+              <a:t>‹N›</a:t>
             </a:fld>
             <a:endParaRPr lang="en-US"/>
           </a:p>
@@ -2625,10 +2666,9 @@
           <a:lstStyle/>
           <a:p>
             <a:r>
-              <a:rPr lang="en-US" smtClean="0"/>
+              <a:rPr lang="en-US"/>
               <a:t>Click to edit Master title style</a:t>
             </a:r>
-            <a:endParaRPr lang="en-US"/>
           </a:p>
         </p:txBody>
       </p:sp>
@@ -2659,38 +2699,37 @@
           <a:p>
             <a:pPr lvl="0"/>
             <a:r>
-              <a:rPr lang="en-US" smtClean="0"/>
+              <a:rPr lang="en-US"/>
               <a:t>Click to edit Master text styles</a:t>
             </a:r>
           </a:p>
           <a:p>
             <a:pPr lvl="1"/>
             <a:r>
-              <a:rPr lang="en-US" smtClean="0"/>
+              <a:rPr lang="en-US"/>
               <a:t>Second level</a:t>
             </a:r>
           </a:p>
           <a:p>
             <a:pPr lvl="2"/>
             <a:r>
-              <a:rPr lang="en-US" smtClean="0"/>
+              <a:rPr lang="en-US"/>
               <a:t>Third level</a:t>
             </a:r>
           </a:p>
           <a:p>
             <a:pPr lvl="3"/>
             <a:r>
-              <a:rPr lang="en-US" smtClean="0"/>
+              <a:rPr lang="en-US"/>
               <a:t>Fourth level</a:t>
             </a:r>
           </a:p>
           <a:p>
             <a:pPr lvl="4"/>
             <a:r>
-              <a:rPr lang="en-US" smtClean="0"/>
+              <a:rPr lang="en-US"/>
               <a:t>Fifth level</a:t>
             </a:r>
-            <a:endParaRPr lang="en-US"/>
           </a:p>
         </p:txBody>
       </p:sp>
@@ -2729,7 +2768,7 @@
           <a:p>
             <a:fld id="{5BCAD085-E8A6-8845-BD4E-CB4CCA059FC4}" type="datetimeFigureOut">
               <a:rPr lang="en-US" smtClean="0"/>
-              <a:t>1/27/13</a:t>
+              <a:t>6/10/2026</a:t>
             </a:fld>
             <a:endParaRPr lang="en-US"/>
           </a:p>
@@ -2807,9 +2846,57 @@
           <a:p>
             <a:fld id="{C1FF6DA9-008F-8B48-92A6-B652298478BF}" type="slidenum">
               <a:rPr lang="en-US" smtClean="0"/>
-              <a:t>‹#›</a:t>
+              <a:t>‹N›</a:t>
             </a:fld>
             <a:endParaRPr lang="en-US"/>
+          </a:p>
+        </p:txBody>
+      </p:sp>
+      <p:sp>
+        <p:nvSpPr>
+          <p:cNvPr id="8" name="CasellaDiTesto 7">
+            <a:extLst>
+              <a:ext uri="{FF2B5EF4-FFF2-40B4-BE49-F238E27FC236}">
+                <a16:creationId xmlns:a16="http://schemas.microsoft.com/office/drawing/2014/main" id="{EB16607D-0606-71E1-27A6-8A3745876565}"/>
+              </a:ext>
+            </a:extLst>
+          </p:cNvPr>
+          <p:cNvSpPr txBox="1"/>
+          <p:nvPr userDrawn="1">
+            <p:extLst>
+              <p:ext uri="{1162E1C5-73C7-4A58-AE30-91384D911F3F}">
+                <p184:classification xmlns:p184="http://schemas.microsoft.com/office/powerpoint/2018/4/main" val="hdr"/>
+              </p:ext>
+            </p:extLst>
+          </p:nvPr>
+        </p:nvSpPr>
+        <p:spPr>
+          <a:xfrm>
+            <a:off x="9556750" y="63500"/>
+            <a:ext cx="2592388" cy="121920"/>
+          </a:xfrm>
+          <a:prstGeom prst="rect">
+            <a:avLst/>
+          </a:prstGeom>
+        </p:spPr>
+        <p:txBody>
+          <a:bodyPr horzOverflow="overflow" lIns="0" tIns="0" rIns="0" bIns="0">
+            <a:spAutoFit/>
+          </a:bodyPr>
+          <a:lstStyle/>
+          <a:p>
+            <a:pPr algn="l"/>
+            <a:r>
+              <a:rPr lang="it-IT" sz="800">
+                <a:solidFill>
+                  <a:srgbClr val="000000">
+                    <a:alpha val="50000"/>
+                  </a:srgbClr>
+                </a:solidFill>
+                <a:latin typeface="Aptos" panose="020B0004020202020204" pitchFamily="34" charset="0"/>
+              </a:rPr>
+              <a:t>CONTENUTO AD USO INTERNO E/O DI TERZI AUTORIZZATI</a:t>
+            </a:r>
           </a:p>
         </p:txBody>
       </p:sp>
@@ -3088,7 +3175,7 @@
 </file>
 
 <file path=ppt/slides/slide1.xml><?xml version="1.0" encoding="utf-8"?>
-<p:sld xmlns:a="http://schemas.openxmlformats.org/drawingml/2006/main" xmlns:p="http://schemas.openxmlformats.org/presentationml/2006/main" xmlns:r="http://schemas.openxmlformats.org/officeDocument/2006/relationships">
+<p:sld xmlns:a="http://schemas.openxmlformats.org/drawingml/2006/main" xmlns:r="http://schemas.openxmlformats.org/officeDocument/2006/relationships" xmlns:p="http://schemas.openxmlformats.org/presentationml/2006/main">
   <p:cSld>
     <p:bg>
       <p:bgPr>
@@ -3104,7 +3191,14 @@
         <p:cNvGrpSpPr/>
         <p:nvPr/>
       </p:nvGrpSpPr>
-      <p:grpSpPr/>
+      <p:grpSpPr>
+        <a:xfrm>
+          <a:off x="0" y="0"/>
+          <a:ext cx="0" cy="0"/>
+          <a:chOff x="0" y="0"/>
+          <a:chExt cx="0" cy="0"/>
+        </a:xfrm>
+      </p:grpSpPr>
       <p:sp>
         <p:nvSpPr>
           <p:cNvPr id="2" name="TextBox 1"/>
@@ -3183,8 +3277,8 @@
         </p:nvSpPr>
         <p:spPr>
           <a:xfrm>
-            <a:off x="731520" y="2743200"/>
-            <a:ext cx="10515600" cy="5029200"/>
+            <a:off x="731520" y="2456795"/>
+            <a:ext cx="10515600" cy="4401205"/>
           </a:xfrm>
           <a:prstGeom prst="rect">
             <a:avLst/>
@@ -3208,6 +3302,7 @@
               </a:defRPr>
             </a:pPr>
             <a:r>
+              <a:rPr dirty="0"/>
               <a:t> Università di Bologna — LM Informatica</a:t>
             </a:r>
           </a:p>
@@ -3223,7 +3318,16 @@
               </a:defRPr>
             </a:pPr>
             <a:r>
-              <a:t> Prof. Picciolomini &amp; Evangelista</a:t>
+              <a:rPr dirty="0"/>
+              <a:t> Prof. </a:t>
+            </a:r>
+            <a:r>
+              <a:rPr dirty="0" err="1"/>
+              <a:t>Picciolomini</a:t>
+            </a:r>
+            <a:r>
+              <a:rPr dirty="0"/>
+              <a:t> &amp; Evangelista</a:t>
             </a:r>
           </a:p>
           <a:p>
@@ -3238,6 +3342,7 @@
               </a:defRPr>
             </a:pPr>
             <a:r>
+              <a:rPr dirty="0"/>
               <a:t> A.A. 2025/2026</a:t>
             </a:r>
           </a:p>
@@ -3253,6 +3358,7 @@
               </a:defRPr>
             </a:pPr>
             <a:r>
+              <a:rPr dirty="0"/>
               <a:t> </a:t>
             </a:r>
           </a:p>
@@ -3267,6 +3373,7 @@
                 </a:solidFill>
               </a:defRPr>
             </a:pPr>
+            <a:endParaRPr dirty="0"/>
           </a:p>
           <a:p>
             <a:pPr>
@@ -3280,8 +3387,22 @@
               </a:defRPr>
             </a:pPr>
             <a:r>
-              <a:t> Metodi: Total Variation • UNet • DiffPIR</a:t>
-            </a:r>
+              <a:rPr dirty="0"/>
+              <a:t> Metodi: Total Variation • </a:t>
+            </a:r>
+            <a:r>
+              <a:rPr dirty="0" err="1"/>
+              <a:t>UNet</a:t>
+            </a:r>
+            <a:r>
+              <a:rPr dirty="0"/>
+              <a:t> • </a:t>
+            </a:r>
+            <a:r>
+              <a:rPr dirty="0" err="1"/>
+              <a:t>DiffPIR</a:t>
+            </a:r>
+            <a:endParaRPr dirty="0"/>
           </a:p>
           <a:p>
             <a:pPr>
@@ -3295,7 +3416,16 @@
               </a:defRPr>
             </a:pPr>
             <a:r>
-              <a:t> Dataset: Mendeley LBC Cervical Cancer (962 immagini)</a:t>
+              <a:rPr dirty="0"/>
+              <a:t> Dataset: Mendeley LBC Cervical Cancer (962 </a:t>
+            </a:r>
+            <a:r>
+              <a:rPr dirty="0" err="1"/>
+              <a:t>immagini</a:t>
+            </a:r>
+            <a:r>
+              <a:rPr dirty="0"/>
+              <a:t>)</a:t>
             </a:r>
           </a:p>
           <a:p>
@@ -3310,6 +3440,7 @@
               </a:defRPr>
             </a:pPr>
             <a:r>
+              <a:rPr dirty="0"/>
               <a:t> </a:t>
             </a:r>
           </a:p>
@@ -3324,6 +3455,7 @@
                 </a:solidFill>
               </a:defRPr>
             </a:pPr>
+            <a:endParaRPr dirty="0"/>
           </a:p>
           <a:p>
             <a:pPr>
@@ -3337,7 +3469,16 @@
               </a:defRPr>
             </a:pPr>
             <a:r>
-              <a:t> François Castaldi &amp; Paolo Fusco — Gruppo R</a:t>
+              <a:rPr dirty="0"/>
+              <a:t> </a:t>
+            </a:r>
+            <a:r>
+              <a:rPr lang="it-IT" dirty="0"/>
+              <a:t>Francesco</a:t>
+            </a:r>
+            <a:r>
+              <a:rPr dirty="0"/>
+              <a:t> Castaldi &amp; Paolo Fusco — Gruppo R</a:t>
             </a:r>
           </a:p>
         </p:txBody>
@@ -3351,7 +3492,7 @@
 </file>
 
 <file path=ppt/slides/slide10.xml><?xml version="1.0" encoding="utf-8"?>
-<p:sld xmlns:a="http://schemas.openxmlformats.org/drawingml/2006/main" xmlns:p="http://schemas.openxmlformats.org/presentationml/2006/main" xmlns:r="http://schemas.openxmlformats.org/officeDocument/2006/relationships">
+<p:sld xmlns:a="http://schemas.openxmlformats.org/drawingml/2006/main" xmlns:r="http://schemas.openxmlformats.org/officeDocument/2006/relationships" xmlns:p="http://schemas.openxmlformats.org/presentationml/2006/main">
   <p:cSld>
     <p:bg>
       <p:bgPr>
@@ -3367,7 +3508,14 @@
         <p:cNvGrpSpPr/>
         <p:nvPr/>
       </p:nvGrpSpPr>
-      <p:grpSpPr/>
+      <p:grpSpPr>
+        <a:xfrm>
+          <a:off x="0" y="0"/>
+          <a:ext cx="0" cy="0"/>
+          <a:chOff x="0" y="0"/>
+          <a:chExt cx="0" cy="0"/>
+        </a:xfrm>
+      </p:grpSpPr>
       <p:sp>
         <p:nvSpPr>
           <p:cNvPr id="2" name="TextBox 1"/>
@@ -3560,6 +3708,7 @@
                 </a:solidFill>
               </a:defRPr>
             </a:pPr>
+            <a:endParaRPr/>
           </a:p>
           <a:p>
             <a:pPr>
@@ -3632,6 +3781,7 @@
                 </a:solidFill>
               </a:defRPr>
             </a:pPr>
+            <a:endParaRPr/>
           </a:p>
           <a:p>
             <a:pPr>
@@ -3734,7 +3884,7 @@
 </file>
 
 <file path=ppt/slides/slide2.xml><?xml version="1.0" encoding="utf-8"?>
-<p:sld xmlns:a="http://schemas.openxmlformats.org/drawingml/2006/main" xmlns:p="http://schemas.openxmlformats.org/presentationml/2006/main" xmlns:r="http://schemas.openxmlformats.org/officeDocument/2006/relationships">
+<p:sld xmlns:a="http://schemas.openxmlformats.org/drawingml/2006/main" xmlns:r="http://schemas.openxmlformats.org/officeDocument/2006/relationships" xmlns:p="http://schemas.openxmlformats.org/presentationml/2006/main">
   <p:cSld>
     <p:bg>
       <p:bgPr>
@@ -3750,7 +3900,14 @@
         <p:cNvGrpSpPr/>
         <p:nvPr/>
       </p:nvGrpSpPr>
-      <p:grpSpPr/>
+      <p:grpSpPr>
+        <a:xfrm>
+          <a:off x="0" y="0"/>
+          <a:ext cx="0" cy="0"/>
+          <a:chOff x="0" y="0"/>
+          <a:chExt cx="0" cy="0"/>
+        </a:xfrm>
+      </p:grpSpPr>
       <p:sp>
         <p:nvSpPr>
           <p:cNvPr id="2" name="TextBox 1"/>
@@ -3883,6 +4040,7 @@
                 </a:solidFill>
               </a:defRPr>
             </a:pPr>
+            <a:endParaRPr/>
           </a:p>
           <a:p>
             <a:pPr>
@@ -3955,6 +4113,7 @@
                 </a:solidFill>
               </a:defRPr>
             </a:pPr>
+            <a:endParaRPr/>
           </a:p>
           <a:p>
             <a:pPr>
@@ -4027,7 +4186,7 @@
 </file>
 
 <file path=ppt/slides/slide3.xml><?xml version="1.0" encoding="utf-8"?>
-<p:sld xmlns:a="http://schemas.openxmlformats.org/drawingml/2006/main" xmlns:p="http://schemas.openxmlformats.org/presentationml/2006/main" xmlns:r="http://schemas.openxmlformats.org/officeDocument/2006/relationships">
+<p:sld xmlns:a="http://schemas.openxmlformats.org/drawingml/2006/main" xmlns:r="http://schemas.openxmlformats.org/officeDocument/2006/relationships" xmlns:p="http://schemas.openxmlformats.org/presentationml/2006/main">
   <p:cSld>
     <p:bg>
       <p:bgPr>
@@ -4043,7 +4202,14 @@
         <p:cNvGrpSpPr/>
         <p:nvPr/>
       </p:nvGrpSpPr>
-      <p:grpSpPr/>
+      <p:grpSpPr>
+        <a:xfrm>
+          <a:off x="0" y="0"/>
+          <a:ext cx="0" cy="0"/>
+          <a:chOff x="0" y="0"/>
+          <a:chExt cx="0" cy="0"/>
+        </a:xfrm>
+      </p:grpSpPr>
       <p:sp>
         <p:nvSpPr>
           <p:cNvPr id="2" name="TextBox 1"/>
@@ -4206,6 +4372,7 @@
                 </a:solidFill>
               </a:defRPr>
             </a:pPr>
+            <a:endParaRPr/>
           </a:p>
           <a:p>
             <a:pPr>
@@ -4293,6 +4460,7 @@
                 </a:solidFill>
               </a:defRPr>
             </a:pPr>
+            <a:endParaRPr/>
           </a:p>
           <a:p>
             <a:pPr>
@@ -4380,7 +4548,7 @@
 </file>
 
 <file path=ppt/slides/slide4.xml><?xml version="1.0" encoding="utf-8"?>
-<p:sld xmlns:a="http://schemas.openxmlformats.org/drawingml/2006/main" xmlns:p="http://schemas.openxmlformats.org/presentationml/2006/main" xmlns:r="http://schemas.openxmlformats.org/officeDocument/2006/relationships">
+<p:sld xmlns:a="http://schemas.openxmlformats.org/drawingml/2006/main" xmlns:r="http://schemas.openxmlformats.org/officeDocument/2006/relationships" xmlns:p="http://schemas.openxmlformats.org/presentationml/2006/main">
   <p:cSld>
     <p:bg>
       <p:bgPr>
@@ -4396,7 +4564,14 @@
         <p:cNvGrpSpPr/>
         <p:nvPr/>
       </p:nvGrpSpPr>
-      <p:grpSpPr/>
+      <p:grpSpPr>
+        <a:xfrm>
+          <a:off x="0" y="0"/>
+          <a:ext cx="0" cy="0"/>
+          <a:chOff x="0" y="0"/>
+          <a:chExt cx="0" cy="0"/>
+        </a:xfrm>
+      </p:grpSpPr>
       <p:sp>
         <p:nvSpPr>
           <p:cNvPr id="2" name="TextBox 1"/>
@@ -4486,10 +4661,34 @@
                 <a:tableStyleId>{5C22544A-7EE6-4342-B048-85BDC9FD1C3A}</a:tableStyleId>
               </a:tblPr>
               <a:tblGrid>
-                <a:gridCol w="1257300"/>
-                <a:gridCol w="1257300"/>
-                <a:gridCol w="1257300"/>
-                <a:gridCol w="1257300"/>
+                <a:gridCol w="1257300">
+                  <a:extLst>
+                    <a:ext uri="{9D8B030D-6E8A-4147-A177-3AD203B41FA5}">
+                      <a16:colId xmlns:a16="http://schemas.microsoft.com/office/drawing/2014/main" val="20000"/>
+                    </a:ext>
+                  </a:extLst>
+                </a:gridCol>
+                <a:gridCol w="1257300">
+                  <a:extLst>
+                    <a:ext uri="{9D8B030D-6E8A-4147-A177-3AD203B41FA5}">
+                      <a16:colId xmlns:a16="http://schemas.microsoft.com/office/drawing/2014/main" val="20001"/>
+                    </a:ext>
+                  </a:extLst>
+                </a:gridCol>
+                <a:gridCol w="1257300">
+                  <a:extLst>
+                    <a:ext uri="{9D8B030D-6E8A-4147-A177-3AD203B41FA5}">
+                      <a16:colId xmlns:a16="http://schemas.microsoft.com/office/drawing/2014/main" val="20002"/>
+                    </a:ext>
+                  </a:extLst>
+                </a:gridCol>
+                <a:gridCol w="1257300">
+                  <a:extLst>
+                    <a:ext uri="{9D8B030D-6E8A-4147-A177-3AD203B41FA5}">
+                      <a16:colId xmlns:a16="http://schemas.microsoft.com/office/drawing/2014/main" val="20003"/>
+                    </a:ext>
+                  </a:extLst>
+                </a:gridCol>
               </a:tblGrid>
               <a:tr h="548640">
                 <a:tc>
@@ -4498,7 +4697,7 @@
                     <a:lstStyle/>
                     <a:p>
                       <a:pPr>
-                        <a:defRPr b="1" sz="1600">
+                        <a:defRPr sz="1600" b="1">
                           <a:solidFill>
                             <a:srgbClr val="1A1A2E"/>
                           </a:solidFill>
@@ -4521,7 +4720,7 @@
                     <a:lstStyle/>
                     <a:p>
                       <a:pPr>
-                        <a:defRPr b="1" sz="1600">
+                        <a:defRPr sz="1600" b="1">
                           <a:solidFill>
                             <a:srgbClr val="1A1A2E"/>
                           </a:solidFill>
@@ -4544,7 +4743,7 @@
                     <a:lstStyle/>
                     <a:p>
                       <a:pPr>
-                        <a:defRPr b="1" sz="1600">
+                        <a:defRPr sz="1600" b="1">
                           <a:solidFill>
                             <a:srgbClr val="1A1A2E"/>
                           </a:solidFill>
@@ -4567,7 +4766,7 @@
                     <a:lstStyle/>
                     <a:p>
                       <a:pPr>
-                        <a:defRPr b="1" sz="1600">
+                        <a:defRPr sz="1600" b="1">
                           <a:solidFill>
                             <a:srgbClr val="1A1A2E"/>
                           </a:solidFill>
@@ -4584,6 +4783,11 @@
                     </a:solidFill>
                   </a:tcPr>
                 </a:tc>
+                <a:extLst>
+                  <a:ext uri="{0D108BD9-81ED-4DB2-BD59-A6C34878D82A}">
+                    <a16:rowId xmlns:a16="http://schemas.microsoft.com/office/drawing/2014/main" val="10000"/>
+                  </a:ext>
+                </a:extLst>
               </a:tr>
               <a:tr h="548640">
                 <a:tc>
@@ -4678,6 +4882,11 @@
                     </a:solidFill>
                   </a:tcPr>
                 </a:tc>
+                <a:extLst>
+                  <a:ext uri="{0D108BD9-81ED-4DB2-BD59-A6C34878D82A}">
+                    <a16:rowId xmlns:a16="http://schemas.microsoft.com/office/drawing/2014/main" val="10001"/>
+                  </a:ext>
+                </a:extLst>
               </a:tr>
               <a:tr h="548640">
                 <a:tc>
@@ -4772,6 +4981,11 @@
                     </a:solidFill>
                   </a:tcPr>
                 </a:tc>
+                <a:extLst>
+                  <a:ext uri="{0D108BD9-81ED-4DB2-BD59-A6C34878D82A}">
+                    <a16:rowId xmlns:a16="http://schemas.microsoft.com/office/drawing/2014/main" val="10002"/>
+                  </a:ext>
+                </a:extLst>
               </a:tr>
               <a:tr h="548640">
                 <a:tc>
@@ -4866,6 +5080,11 @@
                     </a:solidFill>
                   </a:tcPr>
                 </a:tc>
+                <a:extLst>
+                  <a:ext uri="{0D108BD9-81ED-4DB2-BD59-A6C34878D82A}">
+                    <a16:rowId xmlns:a16="http://schemas.microsoft.com/office/drawing/2014/main" val="10003"/>
+                  </a:ext>
+                </a:extLst>
               </a:tr>
               <a:tr h="548640">
                 <a:tc>
@@ -4960,6 +5179,11 @@
                     </a:solidFill>
                   </a:tcPr>
                 </a:tc>
+                <a:extLst>
+                  <a:ext uri="{0D108BD9-81ED-4DB2-BD59-A6C34878D82A}">
+                    <a16:rowId xmlns:a16="http://schemas.microsoft.com/office/drawing/2014/main" val="10004"/>
+                  </a:ext>
+                </a:extLst>
               </a:tr>
             </a:tbl>
           </a:graphicData>
@@ -5027,6 +5251,7 @@
                 </a:solidFill>
               </a:defRPr>
             </a:pPr>
+            <a:endParaRPr/>
           </a:p>
           <a:p>
             <a:pPr>
@@ -5069,7 +5294,7 @@
 </file>
 
 <file path=ppt/slides/slide5.xml><?xml version="1.0" encoding="utf-8"?>
-<p:sld xmlns:a="http://schemas.openxmlformats.org/drawingml/2006/main" xmlns:p="http://schemas.openxmlformats.org/presentationml/2006/main" xmlns:r="http://schemas.openxmlformats.org/officeDocument/2006/relationships">
+<p:sld xmlns:a="http://schemas.openxmlformats.org/drawingml/2006/main" xmlns:r="http://schemas.openxmlformats.org/officeDocument/2006/relationships" xmlns:p="http://schemas.openxmlformats.org/presentationml/2006/main">
   <p:cSld>
     <p:bg>
       <p:bgPr>
@@ -5085,7 +5310,14 @@
         <p:cNvGrpSpPr/>
         <p:nvPr/>
       </p:nvGrpSpPr>
-      <p:grpSpPr/>
+      <p:grpSpPr>
+        <a:xfrm>
+          <a:off x="0" y="0"/>
+          <a:ext cx="0" cy="0"/>
+          <a:chOff x="0" y="0"/>
+          <a:chExt cx="0" cy="0"/>
+        </a:xfrm>
+      </p:grpSpPr>
       <p:sp>
         <p:nvSpPr>
           <p:cNvPr id="2" name="TextBox 1"/>
@@ -5175,11 +5407,41 @@
                 <a:tableStyleId>{5C22544A-7EE6-4342-B048-85BDC9FD1C3A}</a:tableStyleId>
               </a:tblPr>
               <a:tblGrid>
-                <a:gridCol w="1188720"/>
-                <a:gridCol w="1188720"/>
-                <a:gridCol w="1188720"/>
-                <a:gridCol w="1188720"/>
-                <a:gridCol w="1188720"/>
+                <a:gridCol w="1188720">
+                  <a:extLst>
+                    <a:ext uri="{9D8B030D-6E8A-4147-A177-3AD203B41FA5}">
+                      <a16:colId xmlns:a16="http://schemas.microsoft.com/office/drawing/2014/main" val="20000"/>
+                    </a:ext>
+                  </a:extLst>
+                </a:gridCol>
+                <a:gridCol w="1188720">
+                  <a:extLst>
+                    <a:ext uri="{9D8B030D-6E8A-4147-A177-3AD203B41FA5}">
+                      <a16:colId xmlns:a16="http://schemas.microsoft.com/office/drawing/2014/main" val="20001"/>
+                    </a:ext>
+                  </a:extLst>
+                </a:gridCol>
+                <a:gridCol w="1188720">
+                  <a:extLst>
+                    <a:ext uri="{9D8B030D-6E8A-4147-A177-3AD203B41FA5}">
+                      <a16:colId xmlns:a16="http://schemas.microsoft.com/office/drawing/2014/main" val="20002"/>
+                    </a:ext>
+                  </a:extLst>
+                </a:gridCol>
+                <a:gridCol w="1188720">
+                  <a:extLst>
+                    <a:ext uri="{9D8B030D-6E8A-4147-A177-3AD203B41FA5}">
+                      <a16:colId xmlns:a16="http://schemas.microsoft.com/office/drawing/2014/main" val="20003"/>
+                    </a:ext>
+                  </a:extLst>
+                </a:gridCol>
+                <a:gridCol w="1188720">
+                  <a:extLst>
+                    <a:ext uri="{9D8B030D-6E8A-4147-A177-3AD203B41FA5}">
+                      <a16:colId xmlns:a16="http://schemas.microsoft.com/office/drawing/2014/main" val="20004"/>
+                    </a:ext>
+                  </a:extLst>
+                </a:gridCol>
               </a:tblGrid>
               <a:tr h="548640">
                 <a:tc>
@@ -5188,7 +5450,7 @@
                     <a:lstStyle/>
                     <a:p>
                       <a:pPr>
-                        <a:defRPr b="1" sz="1400">
+                        <a:defRPr sz="1400" b="1">
                           <a:solidFill>
                             <a:srgbClr val="1A1A2E"/>
                           </a:solidFill>
@@ -5211,7 +5473,7 @@
                     <a:lstStyle/>
                     <a:p>
                       <a:pPr>
-                        <a:defRPr b="1" sz="1400">
+                        <a:defRPr sz="1400" b="1">
                           <a:solidFill>
                             <a:srgbClr val="1A1A2E"/>
                           </a:solidFill>
@@ -5234,7 +5496,7 @@
                     <a:lstStyle/>
                     <a:p>
                       <a:pPr>
-                        <a:defRPr b="1" sz="1400">
+                        <a:defRPr sz="1400" b="1">
                           <a:solidFill>
                             <a:srgbClr val="1A1A2E"/>
                           </a:solidFill>
@@ -5257,7 +5519,7 @@
                     <a:lstStyle/>
                     <a:p>
                       <a:pPr>
-                        <a:defRPr b="1" sz="1400">
+                        <a:defRPr sz="1400" b="1">
                           <a:solidFill>
                             <a:srgbClr val="1A1A2E"/>
                           </a:solidFill>
@@ -5280,7 +5542,7 @@
                     <a:lstStyle/>
                     <a:p>
                       <a:pPr>
-                        <a:defRPr b="1" sz="1400">
+                        <a:defRPr sz="1400" b="1">
                           <a:solidFill>
                             <a:srgbClr val="1A1A2E"/>
                           </a:solidFill>
@@ -5297,6 +5559,11 @@
                     </a:solidFill>
                   </a:tcPr>
                 </a:tc>
+                <a:extLst>
+                  <a:ext uri="{0D108BD9-81ED-4DB2-BD59-A6C34878D82A}">
+                    <a16:rowId xmlns:a16="http://schemas.microsoft.com/office/drawing/2014/main" val="10000"/>
+                  </a:ext>
+                </a:extLst>
               </a:tr>
               <a:tr h="548640">
                 <a:tc>
@@ -5414,6 +5681,11 @@
                     </a:solidFill>
                   </a:tcPr>
                 </a:tc>
+                <a:extLst>
+                  <a:ext uri="{0D108BD9-81ED-4DB2-BD59-A6C34878D82A}">
+                    <a16:rowId xmlns:a16="http://schemas.microsoft.com/office/drawing/2014/main" val="10001"/>
+                  </a:ext>
+                </a:extLst>
               </a:tr>
               <a:tr h="548640">
                 <a:tc>
@@ -5531,6 +5803,11 @@
                     </a:solidFill>
                   </a:tcPr>
                 </a:tc>
+                <a:extLst>
+                  <a:ext uri="{0D108BD9-81ED-4DB2-BD59-A6C34878D82A}">
+                    <a16:rowId xmlns:a16="http://schemas.microsoft.com/office/drawing/2014/main" val="10002"/>
+                  </a:ext>
+                </a:extLst>
               </a:tr>
               <a:tr h="548640">
                 <a:tc>
@@ -5648,6 +5925,11 @@
                     </a:solidFill>
                   </a:tcPr>
                 </a:tc>
+                <a:extLst>
+                  <a:ext uri="{0D108BD9-81ED-4DB2-BD59-A6C34878D82A}">
+                    <a16:rowId xmlns:a16="http://schemas.microsoft.com/office/drawing/2014/main" val="10003"/>
+                  </a:ext>
+                </a:extLst>
               </a:tr>
               <a:tr h="548640">
                 <a:tc>
@@ -5765,6 +6047,11 @@
                     </a:solidFill>
                   </a:tcPr>
                 </a:tc>
+                <a:extLst>
+                  <a:ext uri="{0D108BD9-81ED-4DB2-BD59-A6C34878D82A}">
+                    <a16:rowId xmlns:a16="http://schemas.microsoft.com/office/drawing/2014/main" val="10004"/>
+                  </a:ext>
+                </a:extLst>
               </a:tr>
             </a:tbl>
           </a:graphicData>
@@ -5832,6 +6119,7 @@
                 </a:solidFill>
               </a:defRPr>
             </a:pPr>
+            <a:endParaRPr/>
           </a:p>
           <a:p>
             <a:pPr>
@@ -5889,7 +6177,7 @@
 </file>
 
 <file path=ppt/slides/slide6.xml><?xml version="1.0" encoding="utf-8"?>
-<p:sld xmlns:a="http://schemas.openxmlformats.org/drawingml/2006/main" xmlns:p="http://schemas.openxmlformats.org/presentationml/2006/main" xmlns:r="http://schemas.openxmlformats.org/officeDocument/2006/relationships">
+<p:sld xmlns:a="http://schemas.openxmlformats.org/drawingml/2006/main" xmlns:r="http://schemas.openxmlformats.org/officeDocument/2006/relationships" xmlns:p="http://schemas.openxmlformats.org/presentationml/2006/main">
   <p:cSld>
     <p:bg>
       <p:bgPr>
@@ -5905,7 +6193,14 @@
         <p:cNvGrpSpPr/>
         <p:nvPr/>
       </p:nvGrpSpPr>
-      <p:grpSpPr/>
+      <p:grpSpPr>
+        <a:xfrm>
+          <a:off x="0" y="0"/>
+          <a:ext cx="0" cy="0"/>
+          <a:chOff x="0" y="0"/>
+          <a:chExt cx="0" cy="0"/>
+        </a:xfrm>
+      </p:grpSpPr>
       <p:sp>
         <p:nvSpPr>
           <p:cNvPr id="2" name="TextBox 1"/>
@@ -5995,11 +6290,41 @@
                 <a:tableStyleId>{5C22544A-7EE6-4342-B048-85BDC9FD1C3A}</a:tableStyleId>
               </a:tblPr>
               <a:tblGrid>
-                <a:gridCol w="1188720"/>
-                <a:gridCol w="1188720"/>
-                <a:gridCol w="1188720"/>
-                <a:gridCol w="1188720"/>
-                <a:gridCol w="1188720"/>
+                <a:gridCol w="1188720">
+                  <a:extLst>
+                    <a:ext uri="{9D8B030D-6E8A-4147-A177-3AD203B41FA5}">
+                      <a16:colId xmlns:a16="http://schemas.microsoft.com/office/drawing/2014/main" val="20000"/>
+                    </a:ext>
+                  </a:extLst>
+                </a:gridCol>
+                <a:gridCol w="1188720">
+                  <a:extLst>
+                    <a:ext uri="{9D8B030D-6E8A-4147-A177-3AD203B41FA5}">
+                      <a16:colId xmlns:a16="http://schemas.microsoft.com/office/drawing/2014/main" val="20001"/>
+                    </a:ext>
+                  </a:extLst>
+                </a:gridCol>
+                <a:gridCol w="1188720">
+                  <a:extLst>
+                    <a:ext uri="{9D8B030D-6E8A-4147-A177-3AD203B41FA5}">
+                      <a16:colId xmlns:a16="http://schemas.microsoft.com/office/drawing/2014/main" val="20002"/>
+                    </a:ext>
+                  </a:extLst>
+                </a:gridCol>
+                <a:gridCol w="1188720">
+                  <a:extLst>
+                    <a:ext uri="{9D8B030D-6E8A-4147-A177-3AD203B41FA5}">
+                      <a16:colId xmlns:a16="http://schemas.microsoft.com/office/drawing/2014/main" val="20003"/>
+                    </a:ext>
+                  </a:extLst>
+                </a:gridCol>
+                <a:gridCol w="1188720">
+                  <a:extLst>
+                    <a:ext uri="{9D8B030D-6E8A-4147-A177-3AD203B41FA5}">
+                      <a16:colId xmlns:a16="http://schemas.microsoft.com/office/drawing/2014/main" val="20004"/>
+                    </a:ext>
+                  </a:extLst>
+                </a:gridCol>
               </a:tblGrid>
               <a:tr h="548640">
                 <a:tc>
@@ -6008,7 +6333,7 @@
                     <a:lstStyle/>
                     <a:p>
                       <a:pPr>
-                        <a:defRPr b="1" sz="1400">
+                        <a:defRPr sz="1400" b="1">
                           <a:solidFill>
                             <a:srgbClr val="1A1A2E"/>
                           </a:solidFill>
@@ -6031,7 +6356,7 @@
                     <a:lstStyle/>
                     <a:p>
                       <a:pPr>
-                        <a:defRPr b="1" sz="1400">
+                        <a:defRPr sz="1400" b="1">
                           <a:solidFill>
                             <a:srgbClr val="1A1A2E"/>
                           </a:solidFill>
@@ -6054,7 +6379,7 @@
                     <a:lstStyle/>
                     <a:p>
                       <a:pPr>
-                        <a:defRPr b="1" sz="1400">
+                        <a:defRPr sz="1400" b="1">
                           <a:solidFill>
                             <a:srgbClr val="1A1A2E"/>
                           </a:solidFill>
@@ -6077,7 +6402,7 @@
                     <a:lstStyle/>
                     <a:p>
                       <a:pPr>
-                        <a:defRPr b="1" sz="1400">
+                        <a:defRPr sz="1400" b="1">
                           <a:solidFill>
                             <a:srgbClr val="1A1A2E"/>
                           </a:solidFill>
@@ -6100,7 +6425,7 @@
                     <a:lstStyle/>
                     <a:p>
                       <a:pPr>
-                        <a:defRPr b="1" sz="1400">
+                        <a:defRPr sz="1400" b="1">
                           <a:solidFill>
                             <a:srgbClr val="1A1A2E"/>
                           </a:solidFill>
@@ -6117,6 +6442,11 @@
                     </a:solidFill>
                   </a:tcPr>
                 </a:tc>
+                <a:extLst>
+                  <a:ext uri="{0D108BD9-81ED-4DB2-BD59-A6C34878D82A}">
+                    <a16:rowId xmlns:a16="http://schemas.microsoft.com/office/drawing/2014/main" val="10000"/>
+                  </a:ext>
+                </a:extLst>
               </a:tr>
               <a:tr h="548640">
                 <a:tc>
@@ -6234,6 +6564,11 @@
                     </a:solidFill>
                   </a:tcPr>
                 </a:tc>
+                <a:extLst>
+                  <a:ext uri="{0D108BD9-81ED-4DB2-BD59-A6C34878D82A}">
+                    <a16:rowId xmlns:a16="http://schemas.microsoft.com/office/drawing/2014/main" val="10001"/>
+                  </a:ext>
+                </a:extLst>
               </a:tr>
               <a:tr h="548640">
                 <a:tc>
@@ -6351,6 +6686,11 @@
                     </a:solidFill>
                   </a:tcPr>
                 </a:tc>
+                <a:extLst>
+                  <a:ext uri="{0D108BD9-81ED-4DB2-BD59-A6C34878D82A}">
+                    <a16:rowId xmlns:a16="http://schemas.microsoft.com/office/drawing/2014/main" val="10002"/>
+                  </a:ext>
+                </a:extLst>
               </a:tr>
               <a:tr h="548640">
                 <a:tc>
@@ -6468,6 +6808,11 @@
                     </a:solidFill>
                   </a:tcPr>
                 </a:tc>
+                <a:extLst>
+                  <a:ext uri="{0D108BD9-81ED-4DB2-BD59-A6C34878D82A}">
+                    <a16:rowId xmlns:a16="http://schemas.microsoft.com/office/drawing/2014/main" val="10003"/>
+                  </a:ext>
+                </a:extLst>
               </a:tr>
               <a:tr h="548640">
                 <a:tc>
@@ -6585,6 +6930,11 @@
                     </a:solidFill>
                   </a:tcPr>
                 </a:tc>
+                <a:extLst>
+                  <a:ext uri="{0D108BD9-81ED-4DB2-BD59-A6C34878D82A}">
+                    <a16:rowId xmlns:a16="http://schemas.microsoft.com/office/drawing/2014/main" val="10004"/>
+                  </a:ext>
+                </a:extLst>
               </a:tr>
             </a:tbl>
           </a:graphicData>
@@ -6652,6 +7002,7 @@
                 </a:solidFill>
               </a:defRPr>
             </a:pPr>
+            <a:endParaRPr/>
           </a:p>
           <a:p>
             <a:pPr>
@@ -6709,7 +7060,7 @@
 </file>
 
 <file path=ppt/slides/slide7.xml><?xml version="1.0" encoding="utf-8"?>
-<p:sld xmlns:a="http://schemas.openxmlformats.org/drawingml/2006/main" xmlns:p="http://schemas.openxmlformats.org/presentationml/2006/main" xmlns:r="http://schemas.openxmlformats.org/officeDocument/2006/relationships">
+<p:sld xmlns:a="http://schemas.openxmlformats.org/drawingml/2006/main" xmlns:r="http://schemas.openxmlformats.org/officeDocument/2006/relationships" xmlns:p="http://schemas.openxmlformats.org/presentationml/2006/main">
   <p:cSld>
     <p:bg>
       <p:bgPr>
@@ -6725,7 +7076,14 @@
         <p:cNvGrpSpPr/>
         <p:nvPr/>
       </p:nvGrpSpPr>
-      <p:grpSpPr/>
+      <p:grpSpPr>
+        <a:xfrm>
+          <a:off x="0" y="0"/>
+          <a:ext cx="0" cy="0"/>
+          <a:chOff x="0" y="0"/>
+          <a:chExt cx="0" cy="0"/>
+        </a:xfrm>
+      </p:grpSpPr>
       <p:sp>
         <p:nvSpPr>
           <p:cNvPr id="2" name="TextBox 1"/>
@@ -6829,7 +7187,7 @@
 </file>
 
 <file path=ppt/slides/slide8.xml><?xml version="1.0" encoding="utf-8"?>
-<p:sld xmlns:a="http://schemas.openxmlformats.org/drawingml/2006/main" xmlns:p="http://schemas.openxmlformats.org/presentationml/2006/main" xmlns:r="http://schemas.openxmlformats.org/officeDocument/2006/relationships">
+<p:sld xmlns:a="http://schemas.openxmlformats.org/drawingml/2006/main" xmlns:r="http://schemas.openxmlformats.org/officeDocument/2006/relationships" xmlns:p="http://schemas.openxmlformats.org/presentationml/2006/main">
   <p:cSld>
     <p:bg>
       <p:bgPr>
@@ -6845,7 +7203,14 @@
         <p:cNvGrpSpPr/>
         <p:nvPr/>
       </p:nvGrpSpPr>
-      <p:grpSpPr/>
+      <p:grpSpPr>
+        <a:xfrm>
+          <a:off x="0" y="0"/>
+          <a:ext cx="0" cy="0"/>
+          <a:chOff x="0" y="0"/>
+          <a:chExt cx="0" cy="0"/>
+        </a:xfrm>
+      </p:grpSpPr>
       <p:sp>
         <p:nvSpPr>
           <p:cNvPr id="2" name="TextBox 1"/>
@@ -6935,11 +7300,41 @@
                 <a:tableStyleId>{5C22544A-7EE6-4342-B048-85BDC9FD1C3A}</a:tableStyleId>
               </a:tblPr>
               <a:tblGrid>
-                <a:gridCol w="2249424"/>
-                <a:gridCol w="2249424"/>
-                <a:gridCol w="2249424"/>
-                <a:gridCol w="2249424"/>
-                <a:gridCol w="2249424"/>
+                <a:gridCol w="2249424">
+                  <a:extLst>
+                    <a:ext uri="{9D8B030D-6E8A-4147-A177-3AD203B41FA5}">
+                      <a16:colId xmlns:a16="http://schemas.microsoft.com/office/drawing/2014/main" val="20000"/>
+                    </a:ext>
+                  </a:extLst>
+                </a:gridCol>
+                <a:gridCol w="2249424">
+                  <a:extLst>
+                    <a:ext uri="{9D8B030D-6E8A-4147-A177-3AD203B41FA5}">
+                      <a16:colId xmlns:a16="http://schemas.microsoft.com/office/drawing/2014/main" val="20001"/>
+                    </a:ext>
+                  </a:extLst>
+                </a:gridCol>
+                <a:gridCol w="2249424">
+                  <a:extLst>
+                    <a:ext uri="{9D8B030D-6E8A-4147-A177-3AD203B41FA5}">
+                      <a16:colId xmlns:a16="http://schemas.microsoft.com/office/drawing/2014/main" val="20002"/>
+                    </a:ext>
+                  </a:extLst>
+                </a:gridCol>
+                <a:gridCol w="2249424">
+                  <a:extLst>
+                    <a:ext uri="{9D8B030D-6E8A-4147-A177-3AD203B41FA5}">
+                      <a16:colId xmlns:a16="http://schemas.microsoft.com/office/drawing/2014/main" val="20003"/>
+                    </a:ext>
+                  </a:extLst>
+                </a:gridCol>
+                <a:gridCol w="2249424">
+                  <a:extLst>
+                    <a:ext uri="{9D8B030D-6E8A-4147-A177-3AD203B41FA5}">
+                      <a16:colId xmlns:a16="http://schemas.microsoft.com/office/drawing/2014/main" val="20004"/>
+                    </a:ext>
+                  </a:extLst>
+                </a:gridCol>
               </a:tblGrid>
               <a:tr h="475488">
                 <a:tc>
@@ -6948,7 +7343,7 @@
                     <a:lstStyle/>
                     <a:p>
                       <a:pPr>
-                        <a:defRPr b="1" sz="1300">
+                        <a:defRPr sz="1300" b="1">
                           <a:solidFill>
                             <a:srgbClr val="1A1A2E"/>
                           </a:solidFill>
@@ -6971,7 +7366,7 @@
                     <a:lstStyle/>
                     <a:p>
                       <a:pPr>
-                        <a:defRPr b="1" sz="1300">
+                        <a:defRPr sz="1300" b="1">
                           <a:solidFill>
                             <a:srgbClr val="1A1A2E"/>
                           </a:solidFill>
@@ -6994,7 +7389,7 @@
                     <a:lstStyle/>
                     <a:p>
                       <a:pPr>
-                        <a:defRPr b="1" sz="1300">
+                        <a:defRPr sz="1300" b="1">
                           <a:solidFill>
                             <a:srgbClr val="1A1A2E"/>
                           </a:solidFill>
@@ -7017,7 +7412,7 @@
                     <a:lstStyle/>
                     <a:p>
                       <a:pPr>
-                        <a:defRPr b="1" sz="1300">
+                        <a:defRPr sz="1300" b="1">
                           <a:solidFill>
                             <a:srgbClr val="1A1A2E"/>
                           </a:solidFill>
@@ -7040,7 +7435,7 @@
                     <a:lstStyle/>
                     <a:p>
                       <a:pPr>
-                        <a:defRPr b="1" sz="1300">
+                        <a:defRPr sz="1300" b="1">
                           <a:solidFill>
                             <a:srgbClr val="1A1A2E"/>
                           </a:solidFill>
@@ -7057,6 +7452,11 @@
                     </a:solidFill>
                   </a:tcPr>
                 </a:tc>
+                <a:extLst>
+                  <a:ext uri="{0D108BD9-81ED-4DB2-BD59-A6C34878D82A}">
+                    <a16:rowId xmlns:a16="http://schemas.microsoft.com/office/drawing/2014/main" val="10000"/>
+                  </a:ext>
+                </a:extLst>
               </a:tr>
               <a:tr h="475488">
                 <a:tc>
@@ -7174,6 +7574,11 @@
                     </a:solidFill>
                   </a:tcPr>
                 </a:tc>
+                <a:extLst>
+                  <a:ext uri="{0D108BD9-81ED-4DB2-BD59-A6C34878D82A}">
+                    <a16:rowId xmlns:a16="http://schemas.microsoft.com/office/drawing/2014/main" val="10001"/>
+                  </a:ext>
+                </a:extLst>
               </a:tr>
               <a:tr h="475488">
                 <a:tc>
@@ -7291,6 +7696,11 @@
                     </a:solidFill>
                   </a:tcPr>
                 </a:tc>
+                <a:extLst>
+                  <a:ext uri="{0D108BD9-81ED-4DB2-BD59-A6C34878D82A}">
+                    <a16:rowId xmlns:a16="http://schemas.microsoft.com/office/drawing/2014/main" val="10002"/>
+                  </a:ext>
+                </a:extLst>
               </a:tr>
               <a:tr h="475488">
                 <a:tc>
@@ -7408,6 +7818,11 @@
                     </a:solidFill>
                   </a:tcPr>
                 </a:tc>
+                <a:extLst>
+                  <a:ext uri="{0D108BD9-81ED-4DB2-BD59-A6C34878D82A}">
+                    <a16:rowId xmlns:a16="http://schemas.microsoft.com/office/drawing/2014/main" val="10003"/>
+                  </a:ext>
+                </a:extLst>
               </a:tr>
               <a:tr h="475488">
                 <a:tc>
@@ -7525,6 +7940,11 @@
                     </a:solidFill>
                   </a:tcPr>
                 </a:tc>
+                <a:extLst>
+                  <a:ext uri="{0D108BD9-81ED-4DB2-BD59-A6C34878D82A}">
+                    <a16:rowId xmlns:a16="http://schemas.microsoft.com/office/drawing/2014/main" val="10004"/>
+                  </a:ext>
+                </a:extLst>
               </a:tr>
               <a:tr h="475488">
                 <a:tc>
@@ -7642,6 +8062,11 @@
                     </a:solidFill>
                   </a:tcPr>
                 </a:tc>
+                <a:extLst>
+                  <a:ext uri="{0D108BD9-81ED-4DB2-BD59-A6C34878D82A}">
+                    <a16:rowId xmlns:a16="http://schemas.microsoft.com/office/drawing/2014/main" val="10005"/>
+                  </a:ext>
+                </a:extLst>
               </a:tr>
               <a:tr h="475488">
                 <a:tc>
@@ -7759,6 +8184,11 @@
                     </a:solidFill>
                   </a:tcPr>
                 </a:tc>
+                <a:extLst>
+                  <a:ext uri="{0D108BD9-81ED-4DB2-BD59-A6C34878D82A}">
+                    <a16:rowId xmlns:a16="http://schemas.microsoft.com/office/drawing/2014/main" val="10006"/>
+                  </a:ext>
+                </a:extLst>
               </a:tr>
               <a:tr h="475488">
                 <a:tc>
@@ -7876,6 +8306,11 @@
                     </a:solidFill>
                   </a:tcPr>
                 </a:tc>
+                <a:extLst>
+                  <a:ext uri="{0D108BD9-81ED-4DB2-BD59-A6C34878D82A}">
+                    <a16:rowId xmlns:a16="http://schemas.microsoft.com/office/drawing/2014/main" val="10007"/>
+                  </a:ext>
+                </a:extLst>
               </a:tr>
               <a:tr h="475488">
                 <a:tc>
@@ -7890,6 +8325,7 @@
                           </a:solidFill>
                         </a:defRPr>
                       </a:pPr>
+                      <a:endParaRPr/>
                     </a:p>
                   </a:txBody>
                   <a:tcPr>
@@ -7990,6 +8426,11 @@
                     </a:solidFill>
                   </a:tcPr>
                 </a:tc>
+                <a:extLst>
+                  <a:ext uri="{0D108BD9-81ED-4DB2-BD59-A6C34878D82A}">
+                    <a16:rowId xmlns:a16="http://schemas.microsoft.com/office/drawing/2014/main" val="10008"/>
+                  </a:ext>
+                </a:extLst>
               </a:tr>
               <a:tr h="475488">
                 <a:tc>
@@ -8004,6 +8445,7 @@
                           </a:solidFill>
                         </a:defRPr>
                       </a:pPr>
+                      <a:endParaRPr/>
                     </a:p>
                   </a:txBody>
                   <a:tcPr>
@@ -8104,6 +8546,11 @@
                     </a:solidFill>
                   </a:tcPr>
                 </a:tc>
+                <a:extLst>
+                  <a:ext uri="{0D108BD9-81ED-4DB2-BD59-A6C34878D82A}">
+                    <a16:rowId xmlns:a16="http://schemas.microsoft.com/office/drawing/2014/main" val="10009"/>
+                  </a:ext>
+                </a:extLst>
               </a:tr>
             </a:tbl>
           </a:graphicData>
@@ -8118,7 +8565,7 @@
 </file>
 
 <file path=ppt/slides/slide9.xml><?xml version="1.0" encoding="utf-8"?>
-<p:sld xmlns:a="http://schemas.openxmlformats.org/drawingml/2006/main" xmlns:p="http://schemas.openxmlformats.org/presentationml/2006/main" xmlns:r="http://schemas.openxmlformats.org/officeDocument/2006/relationships">
+<p:sld xmlns:a="http://schemas.openxmlformats.org/drawingml/2006/main" xmlns:r="http://schemas.openxmlformats.org/officeDocument/2006/relationships" xmlns:p="http://schemas.openxmlformats.org/presentationml/2006/main">
   <p:cSld>
     <p:bg>
       <p:bgPr>
@@ -8134,7 +8581,14 @@
         <p:cNvGrpSpPr/>
         <p:nvPr/>
       </p:nvGrpSpPr>
-      <p:grpSpPr/>
+      <p:grpSpPr>
+        <a:xfrm>
+          <a:off x="0" y="0"/>
+          <a:ext cx="0" cy="0"/>
+          <a:chOff x="0" y="0"/>
+          <a:chExt cx="0" cy="0"/>
+        </a:xfrm>
+      </p:grpSpPr>
       <p:sp>
         <p:nvSpPr>
           <p:cNvPr id="2" name="TextBox 1"/>
@@ -8267,6 +8721,7 @@
                 </a:solidFill>
               </a:defRPr>
             </a:pPr>
+            <a:endParaRPr/>
           </a:p>
           <a:p>
             <a:pPr>
@@ -8309,6 +8764,7 @@
                 </a:solidFill>
               </a:defRPr>
             </a:pPr>
+            <a:endParaRPr/>
           </a:p>
           <a:p>
             <a:pPr>
@@ -8366,6 +8822,7 @@
                 </a:solidFill>
               </a:defRPr>
             </a:pPr>
+            <a:endParaRPr/>
           </a:p>
           <a:p>
             <a:pPr>

</xml_diff>